<commit_message>
desafio projeto 1 - finalizado
</commit_message>
<xml_diff>
--- a/[Desafio de Projeto 1] Analisando dados de um Dashboard de Vendas no Power BI.pptx
+++ b/[Desafio de Projeto 1] Analisando dados de um Dashboard de Vendas no Power BI.pptx
@@ -5,11 +5,12 @@
     <p:sldMasterId id="2147483648" r:id="rId1"/>
   </p:sldMasterIdLst>
   <p:notesMasterIdLst>
-    <p:notesMasterId r:id="rId4"/>
+    <p:notesMasterId r:id="rId5"/>
   </p:notesMasterIdLst>
   <p:sldIdLst>
     <p:sldId id="257" r:id="rId2"/>
     <p:sldId id="258" r:id="rId3"/>
+    <p:sldId id="259" r:id="rId4"/>
   </p:sldIdLst>
   <p:sldSz cx="12192000" cy="6858000"/>
   <p:notesSz cx="6858000" cy="9144000"/>
@@ -108,6 +109,11 @@
       </a:defRPr>
     </a:lvl9pPr>
   </p:defaultTextStyle>
+  <p:extLst>
+    <p:ext uri="{EFAFB233-063F-42B5-8137-9DF3F51BA10A}">
+      <p15:sldGuideLst xmlns:p15="http://schemas.microsoft.com/office/powerpoint/2012/main"/>
+    </p:ext>
+  </p:extLst>
 </p:presentation>
 </file>
 
@@ -3986,6 +3992,133 @@
     <p:extLst>
       <p:ext uri="{BB962C8B-B14F-4D97-AF65-F5344CB8AC3E}">
         <p14:creationId xmlns:p14="http://schemas.microsoft.com/office/powerpoint/2010/main" val="299896624"/>
+      </p:ext>
+    </p:extLst>
+  </p:cSld>
+  <p:clrMapOvr>
+    <a:masterClrMapping/>
+  </p:clrMapOvr>
+</p:sld>
+</file>
+
+<file path=ppt/slides/slide3.xml><?xml version="1.0" encoding="utf-8"?>
+<p:sld xmlns:a="http://schemas.openxmlformats.org/drawingml/2006/main" xmlns:r="http://schemas.openxmlformats.org/officeDocument/2006/relationships" xmlns:p="http://schemas.openxmlformats.org/presentationml/2006/main">
+  <p:cSld>
+    <p:spTree>
+      <p:nvGrpSpPr>
+        <p:cNvPr id="1" name=""/>
+        <p:cNvGrpSpPr/>
+        <p:nvPr/>
+      </p:nvGrpSpPr>
+      <p:grpSpPr>
+        <a:xfrm>
+          <a:off x="0" y="0"/>
+          <a:ext cx="0" cy="0"/>
+          <a:chOff x="0" y="0"/>
+          <a:chExt cx="0" cy="0"/>
+        </a:xfrm>
+      </p:grpSpPr>
+      <p:sp>
+        <p:nvSpPr>
+          <p:cNvPr id="2" name="Título 1">
+            <a:extLst>
+              <a:ext uri="{FF2B5EF4-FFF2-40B4-BE49-F238E27FC236}">
+                <a16:creationId xmlns:a16="http://schemas.microsoft.com/office/drawing/2014/main" id="{7884FA3B-620B-B063-EFFE-83E91722123A}"/>
+              </a:ext>
+            </a:extLst>
+          </p:cNvPr>
+          <p:cNvSpPr>
+            <a:spLocks noGrp="1"/>
+          </p:cNvSpPr>
+          <p:nvPr>
+            <p:ph type="title"/>
+          </p:nvPr>
+        </p:nvSpPr>
+        <p:spPr/>
+        <p:txBody>
+          <a:bodyPr/>
+          <a:lstStyle/>
+          <a:p>
+            <a:r>
+              <a:rPr lang="pt-BR"/>
+              <a:t>Geográfico2</a:t>
+            </a:r>
+          </a:p>
+          <a:p>
+            <a:r>
+              <a:rPr lang="pt-BR" sz="2800"/>
+              <a:t>Sample - Financial Data</a:t>
+            </a:r>
+            <a:endParaRPr lang="pt-BR"/>
+          </a:p>
+        </p:txBody>
+      </p:sp>
+      <mc:AlternateContent xmlns:mc="http://schemas.openxmlformats.org/markup-compatibility/2006">
+        <mc:Choice xmlns:we="http://schemas.microsoft.com/office/webextensions/webextension/2010/11" xmlns:pca="http://schemas.microsoft.com/office/powerpoint/2013/contentapp" Requires="we pca">
+          <p:graphicFrame>
+            <p:nvGraphicFramePr>
+              <p:cNvPr id="4" name="Espaço Reservado para Conteúdo 3">
+                <a:extLst>
+                  <a:ext uri="{FF2B5EF4-FFF2-40B4-BE49-F238E27FC236}">
+                    <a16:creationId xmlns:a16="http://schemas.microsoft.com/office/drawing/2014/main" id="{B71CB547-CC67-B842-3329-606DECB89123}"/>
+                  </a:ext>
+                </a:extLst>
+              </p:cNvPr>
+              <p:cNvGraphicFramePr>
+                <a:graphicFrameLocks noGrp="1"/>
+              </p:cNvGraphicFramePr>
+              <p:nvPr>
+                <p:ph idx="1"/>
+              </p:nvPr>
+            </p:nvGraphicFramePr>
+            <p:xfrm>
+              <a:off x="838200" y="1825625"/>
+              <a:ext cx="10515600" cy="4351338"/>
+            </p:xfrm>
+            <a:graphic>
+              <a:graphicData uri="http://schemas.microsoft.com/office/webextensions/webextension/2010/11">
+                <we:webextensionref xmlns:we="http://schemas.microsoft.com/office/webextensions/webextension/2010/11" xmlns:r="http://schemas.openxmlformats.org/officeDocument/2006/relationships" r:id="rId2"/>
+              </a:graphicData>
+            </a:graphic>
+          </p:graphicFrame>
+        </mc:Choice>
+        <mc:Fallback>
+          <p:pic>
+            <p:nvPicPr>
+              <p:cNvPr id="4" name="Espaço Reservado para Conteúdo 3">
+                <a:extLst>
+                  <a:ext uri="{FF2B5EF4-FFF2-40B4-BE49-F238E27FC236}">
+                    <a16:creationId xmlns:a16="http://schemas.microsoft.com/office/drawing/2014/main" id="{B71CB547-CC67-B842-3329-606DECB89123}"/>
+                  </a:ext>
+                </a:extLst>
+              </p:cNvPr>
+              <p:cNvPicPr>
+                <a:picLocks noGrp="1" noRot="1" noChangeAspect="1" noMove="1" noResize="1" noEditPoints="1" noAdjustHandles="1" noChangeArrowheads="1" noChangeShapeType="1"/>
+              </p:cNvPicPr>
+              <p:nvPr/>
+            </p:nvPicPr>
+            <p:blipFill>
+              <a:blip r:embed="rId3"/>
+              <a:stretch>
+                <a:fillRect/>
+              </a:stretch>
+            </p:blipFill>
+            <p:spPr>
+              <a:xfrm>
+                <a:off x="838200" y="1825625"/>
+                <a:ext cx="10515600" cy="4351338"/>
+              </a:xfrm>
+              <a:prstGeom prst="rect">
+                <a:avLst/>
+              </a:prstGeom>
+            </p:spPr>
+          </p:pic>
+        </mc:Fallback>
+      </mc:AlternateContent>
+    </p:spTree>
+    <p:extLst>
+      <p:ext uri="{BB962C8B-B14F-4D97-AF65-F5344CB8AC3E}">
+        <p14:creationId xmlns:p14="http://schemas.microsoft.com/office/powerpoint/2010/main" val="2121361912"/>
       </p:ext>
     </p:extLst>
   </p:cSld>
@@ -4632,22 +4765,22 @@
     <we:reference id="wa200003233" version="2.0.0.3" store="pt-BR" storeType="OMEX"/>
   </we:alternateReferences>
   <we:properties>
-    <we:property name="reportUrl" value="&quot;/links/GSl1XJDFxa?ctid=e2aa239f-a4fc-47c9-95a0-e1cf88e3e171&amp;pbi_source=linkShare&amp;bookmarkGuid=58d9cbf4-de9a-4d24-87b4-1b2af008c79e&quot;"/>
-    <we:property name="reportName" value="&quot;Sample - Financial Data&quot;"/>
-    <we:property name="reportState" value="&quot;CONNECTED&quot;"/>
-    <we:property name="embedUrl" value="&quot;/reportEmbed?reportId=06ec5cce-0c97-4bba-ac4a-ad9536ee1188&amp;config=eyJjbHVzdGVyVXJsIjoiaHR0cHM6Ly9XQUJJLUJSQVpJTC1TT1VUSC1yZWRpcmVjdC5hbmFseXNpcy53aW5kb3dzLm5ldCIsImVtYmVkRmVhdHVyZXMiOnsidXNhZ2VNZXRyaWNzVk5leHQiOnRydWV9fQ%3D%3D&amp;disableSensitivityBanner=true&quot;"/>
-    <we:property name="pageDisplayName" value="&quot;Produtos&quot;"/>
-    <we:property name="datasetId" value="&quot;24f7b612-ab78-4878-8567-8ec2cbc09cb2&quot;"/>
+    <we:property name="artifactViewState" value="&quot;live&quot;"/>
     <we:property name="backgroundColor" value="&quot;#F6F7F8&quot;"/>
     <we:property name="bookmark" value="&quot;H4sIAAAAAAAAA+1X227cNhD9FYMveVkEuq0ufms2eSgaF4uuEaAI9mFEjtYMaFIlKddbY7+n6HfkxzqkIt+yTlLDlxTIPkkzszNnzpyRqAsmpOsVbH+FU2SH7GctJAdh7EHKZkyPxg66OqsKDkUFvE3ztpwDeU3vpdGOHV4wD3aD/p10A6iQiYzv1zMGSi1hE+46UA5nrEfrjAYl/8IxmFzeDribMTzvlbEQUq48eAxpzyic7glC+jKnisC9PMMVcj9ahaibZN6URV1XXPAmr5IA240BEdnekJA6ll8Y7UFqKhNsbd7VeZZlUGcpT+smrZIIo5PKTyHbN+e9pe6o520fyPlJnIHmKFhswaIbEV+wIwQ32JjgzQ3HygyW42/YRZf20m8pzxEKKcCxHXGxtIaYiuZj40EdrEDh6Doxfy4sEj+CHSa72SWMBZk2xtLw1GdIFkYNp/pbgXRSU0MyzOYWFroUA/d7cKzJ4qTeqE9jvWL4eITXS1ycgPVBNu0Hmk9gk/5krED7ahsJfS3tNNlsdgvqY5C5W0+KopAP1zTzicsR1cOTt94FF3QNlnmT1aKoeZlXRVInXxXb80559lSiP/r4j5BwsLT48W+zT/df1RtQ7HcguM8aeV7NlQnyRIDIi7Rsq6Zrqzb98YC7wrLCzSnqe0r/oUD8jmCfnYkjejGeHMRDwT22j6vBkaBQjHD+yyKmtxfxgWkNPD5FuSspPe3KT+p5JCmMzxFMEp7Ms66DpiuK+TztRHX/58iPxblcHKckR3tjVdgp0tk6HmXBQyS0H8tJHP1GRDdGvi/YW0kzGHO/AzWEtC9egZP8RRBjHOEdgozh7v8lxzhH0G76bBjhW6Pi1dQSraDCM1Sj948B7ZYqxoirSi8jWAqVjsAq6F2YWvg8IZPACO0X3D4KQbHqUmo9lQyU3YXzGgV3oL2ZioKsMT4gmvqYRq0HpWaMn0glLOrY2e2Q93sllSVp/nYCfmw2pOlryL85R3FHjvWk06YtRZZCVVa8rugrrhTxlPzFLfJ47ltzfvONE3/7F8sM3vXAcQka9yxYFJgI0L64ZPET93LFdrt/AbA0BSpbDwAA&quot;"/>
+    <we:property name="creatorSessionId" value="&quot;e147b3d8-711d-4c05-9cb7-1c436c9deb8e&quot;"/>
+    <we:property name="creatorTenantId" value="&quot;e2aa239f-a4fc-47c9-95a0-e1cf88e3e171&quot;"/>
+    <we:property name="creatorUserId" value="&quot;10032000ED6ECE74&quot;"/>
+    <we:property name="datasetId" value="&quot;24f7b612-ab78-4878-8567-8ec2cbc09cb2&quot;"/>
+    <we:property name="embedUrl" value="&quot;/reportEmbed?reportId=06ec5cce-0c97-4bba-ac4a-ad9536ee1188&amp;config=eyJjbHVzdGVyVXJsIjoiaHR0cHM6Ly9XQUJJLUJSQVpJTC1TT1VUSC1yZWRpcmVjdC5hbmFseXNpcy53aW5kb3dzLm5ldCIsImVtYmVkRmVhdHVyZXMiOnsidXNhZ2VNZXRyaWNzVk5leHQiOnRydWV9fQ%3D%3D&amp;disableSensitivityBanner=true&quot;"/>
     <we:property name="initialStateBookmark" value="&quot;H4sIAAAAAAAAA+1X227TQBD9lWpfeImQ7aSx3bc29AGVQEQqJIQiNNkdp4u2u2Z3XRqqfA/iO/gxZte417SFqheQyJM9M5k5c+aMvT5hQrpawfI1HCLbYi+1kByEsRsp6zHdGnfevNkbb7/d+/h6e7xLZlN7abRjWyfMg12gfyddAyqkIOOHWY+BUhNYhLsKlMMeq9E6o0HJr9gGk8vbBlc9hse1MhZCyqkHjyHtEYXTPdVOn/epInAvj3CK3LdWIYoy2SyHg6LIueBlP08CXtcGRGRrQ0LqWH5ktAepqUywzftV0c+yDIos5WlRpnkSYVRS+S5kuXtcW+qOel7WgZVtcQSao2CxBYuuRXzCxgiusTHB7gXH1DSW41usokt76ZeUZ4xCCnBsRVxMrCGmonnfeFAbU1DYug7Ml5FF4kewrWTVO4UxItPCWJqauoJkZFRzqH8XSCU1NSTDbC5hoUvRcL8Gx4wsTuqF+jXWM4b3W3i1xNEBWB9kM/9E8wls0p+MFWh3lpHQF9J2k816l6A+BJmrWacoCvl0TjO/uGxR3T95s1VwQVXisF9mhRgUfNjPB0mR3Cq2p51y77FEP/7xXUjYmFj88c2s0/2tegOK/QsEd6WRp9XcMEGeCBD9QTqc52U1z+fp/wfcGZYpLg5R31H69wXiPYJ9cibG9GI82IingTtsH1eNI0GhaOH8ySKmlxfxnmkNPD5GuTMpPe7Kd+p5ICm0zxFMEp5sZlUFZTUYbG6mlcjv/hz5vzini+OU5GgvrAo7RDpbx6MseIiE1m05ia3fiOjGyPcJeyVpBm3ud6CakPbZDjjJnwUxxhFeI8gY7v4tOcY5gnbdZ0ML3xoVr7qWaAUVHqFqvZ8btEuqGCPOKj2PYClUOgKroHZhauHzhEwCI7Q9XD4IQbHqRGrdlQyUXYfzHAXXoL2YioKsMT4g6vroRq0bpXqMH0glLOrY2eWQD2sllSVp/1UHfN8sSNPnkP92jsE1OWadTsv5UGQp5MOcFzl9xQ1FPCXfuEUej/3cHF9848Tf+sUyjXc1cJyAxjULFgUmArQblyx+4sY3TEAj5+q2rQyNnq7kavUT9IkNPoQPAAA=&quot;"/>
     <we:property name="isFiltersActionButtonVisible" value="true"/>
     <we:property name="isVisualContainerHeaderHidden" value="false"/>
+    <we:property name="pageDisplayName" value="&quot;Produtos&quot;"/>
     <we:property name="reportEmbeddedTime" value="&quot;2024-06-19T16:26:41.030Z&quot;"/>
-    <we:property name="creatorTenantId" value="&quot;e2aa239f-a4fc-47c9-95a0-e1cf88e3e171&quot;"/>
-    <we:property name="creatorUserId" value="&quot;10032000ED6ECE74&quot;"/>
-    <we:property name="creatorSessionId" value="&quot;e147b3d8-711d-4c05-9cb7-1c436c9deb8e&quot;"/>
-    <we:property name="artifactViewState" value="&quot;live&quot;"/>
+    <we:property name="reportName" value="&quot;Sample - Financial Data&quot;"/>
+    <we:property name="reportState" value="&quot;CONNECTED&quot;"/>
+    <we:property name="reportUrl" value="&quot;/links/GSl1XJDFxa?ctid=e2aa239f-a4fc-47c9-95a0-e1cf88e3e171&amp;pbi_source=linkShare&amp;bookmarkGuid=58d9cbf4-de9a-4d24-87b4-1b2af008c79e&quot;"/>
   </we:properties>
   <we:bindings/>
   <we:snapshot xmlns:r="http://schemas.openxmlformats.org/officeDocument/2006/relationships"/>
@@ -4661,21 +4794,50 @@
     <we:reference id="wa200003233" version="2.0.0.3" store="pt-BR" storeType="OMEX"/>
   </we:alternateReferences>
   <we:properties>
+    <we:property name="artifactViewState" value="&quot;live&quot;"/>
+    <we:property name="backgroundColor" value="&quot;#F6F7F8&quot;"/>
+    <we:property name="bookmark" value="&quot;H4sIAAAAAAAAA+1XyW7bMBD9lYBno9C+5Na6ORRoiqBOAxSFD0Ny5DBgKIGiUruB/71DKm6WGmkQZHGAniTOjGZ5bzikLplUfadh9QXOke2zT0YqAbK1ezGbMDMKkyouK15EcVbLqinjpOYFadvOqdb0bP+SObALdCeqH0B7TyT8MZ8w0PoIFn7VgO5xwjq0fWtAq184GpPK2QHXE4bLTrcWvMuZA4fe7QWZ05pSiN+lFBGEUxc4Q+FGaVNnPColB5FnHGReyzwhs340CJltNfGuQ/hpaxwoQ2G8jDcpFjJOuairuIlE0eSVl/fKLPRVwtffHq86D47DpePt0uPBzyiw97ReU0GQJZxCo6xE3OR1wssseGuUdpuAq4NlZwkrQnD09l5egBEoWQDEYj/Wf8kOEfrBBlQObilm7WAFfsUmqIxTbkV+DlEqCT3ziRzZlnAP4uPWgd6bgcZRddr+nFoktCXbj9ZzktxbqwArbxdKCyvRfliFIj4qu+EmmdzJ8zkKoIxJzaOKo5Bc5DyNsyaFuBC7AfQ3QzqJ/d4JmmuzNwr6tmJGAkrOq6SM0roWcSZyUYGs/0nAlABYtJamjf6Lg2mrh3Pz0KwbZYhK5YfJncSn7WCcXW1BffKyjUCCRrnHsN8pnJ6CdbvQAX+qWM83s5hEZzem7RWpY1pPz+I8DNaoyupSYJyUUHDgMZRFshv7/fE078omv0Gx1ycRSJmXeRNlUcmzSOaYPh7qp2qI7wj23j39ErPlkK4Op3vh2vSGx4vQQ09Mohxh2TpqXm6nb4h9JpbG8ZGkgGXGsyRqYkyjpEiK8v9p9TT3wwd00+veF1/v3Aq9d40EO0f6ZfIv7eD6DgQegcEQvxtdKAx2RDMY6QkI79Y/PytCecT/BPTgoQ8/WCyECdF+AyE8qfvZDQAA&quot;"/>
+    <we:property name="creatorSessionId" value="&quot;a54d71c8-1ea6-4f8a-acf6-1dd9ccc89e61&quot;"/>
+    <we:property name="creatorTenantId" value="&quot;e2aa239f-a4fc-47c9-95a0-e1cf88e3e171&quot;"/>
+    <we:property name="creatorUserId" value="&quot;10032000ED6ECE74&quot;"/>
+    <we:property name="datasetId" value="&quot;24f7b612-ab78-4878-8567-8ec2cbc09cb2&quot;"/>
+    <we:property name="embedUrl" value="&quot;/reportEmbed?reportId=06ec5cce-0c97-4bba-ac4a-ad9536ee1188&amp;config=eyJjbHVzdGVyVXJsIjoiaHR0cHM6Ly9XQUJJLUJSQVpJTC1TT1VUSC1yZWRpcmVjdC5hbmFseXNpcy53aW5kb3dzLm5ldCIsImVtYmVkRmVhdHVyZXMiOnsidXNhZ2VNZXRyaWNzVk5leHQiOnRydWV9fQ%3D%3D&amp;disableSensitivityBanner=true&quot;"/>
+    <we:property name="initialStateBookmark" value="&quot;H4sIAAAAAAAAA+1X204bMRD9FeTnqNprNuENUh4qGkCEIlVVVI3t2WBkvCuvlyZF+feOvaRcGgFCXILUp13PzM7lnPGsfcWkamoNiwO4QLbNvhipBMjKbsWsx0wn3D083B/vHO//PNgZ75G4qp2qTMO2r5gDO0N3qpoWtHdBwh/THgOtj2DmVyXoBnusRttUBrT6jZ0xqZxtcdljOK91ZcG7nDhw6N1ekjmtKXb8KaWIIJy6xAkK10nLYcajQnIQecZB5kOZJ2TWdAYhs7Um3nUIP6qMA2UojJfxMsW+jFMuhoO4jES/zAde3igz09cJ33x7sqg9Kg7njldzjwc/p8De03JJBUGWcAqNciDiMh8mvMiCt1Jptwq42JvXlrAiBDtvO/ISjEDJAiAWm67+KzZGaFobUNm7o5hUrRV4jGVQGafcgvyMUSoJDfOJHNmKcA/ik8qB3pqAxk51Vv0aWSS0JduOllOSPFirACvvFkoLK9HuLkIRn5VdcZP07uX5GgVQxqTm0YCjkFzkPI2zMoW4LzYD6G+GdBKbrVM0N2YfFPR1xXQEFJwPkiJKh0MRZyIXA5DDRwkYEQCzytKY0f9wMKp0e2GemnWpDFGp/DC5l/ioao2zizWo9962EUhQKvcc9muFozOwbhM64G8Vy+lqFpPo/Na0vSa1S+vlWZyGwRoNsmEhME4K6HPgMRT9ZDP2+/Np3pRNfotir08ikDIv8jLKooJnkcwxfT7UL9UQ3xHsg3v6LWbLmI4OZ1vhvPSBx4vQbUNMouxgWTtq3m6nr4h9JZa68ZGkgEXGsyQqY0yjpJ/0i/9/q5c5Hz6hm973vPh+/63QezdIsAukK5N/qVrX1CDwCAyG+HXnQmGwI5rBSE9AeLf++VURyh3+p6BbD324YLEQhChRXOMjH/hrFwtphez+AL1KzXsCDgAA&quot;"/>
+    <we:property name="isFiltersActionButtonVisible" value="true"/>
+    <we:property name="isVisualContainerHeaderHidden" value="false"/>
+    <we:property name="pageDisplayName" value="&quot;Geográfico&quot;"/>
+    <we:property name="reportEmbeddedTime" value="&quot;2024-06-19T16:27:31.551Z&quot;"/>
+    <we:property name="reportName" value="&quot;Sample - Financial Data&quot;"/>
+    <we:property name="reportState" value="&quot;CONNECTED&quot;"/>
     <we:property name="reportUrl" value="&quot;/links/GSl1XJDFxa?ctid=e2aa239f-a4fc-47c9-95a0-e1cf88e3e171&amp;pbi_source=linkShare&quot;"/>
+  </we:properties>
+  <we:bindings/>
+  <we:snapshot xmlns:r="http://schemas.openxmlformats.org/officeDocument/2006/relationships"/>
+</we:webextension>
+</file>
+
+<file path=ppt/webextensions/webextension3.xml><?xml version="1.0" encoding="utf-8"?>
+<we:webextension xmlns:we="http://schemas.microsoft.com/office/webextensions/webextension/2010/11" id="{B89CB8D2-86FD-466D-9269-47545D31A74E}">
+  <we:reference id="wa200003233" version="2.0.0.3" store="pt-BR" storeType="OMEX"/>
+  <we:alternateReferences>
+    <we:reference id="wa200003233" version="2.0.0.3" store="pt-BR" storeType="OMEX"/>
+  </we:alternateReferences>
+  <we:properties>
+    <we:property name="reportUrl" value="&quot;/links/GSl1XJDFxa?ctid=e2aa239f-a4fc-47c9-95a0-e1cf88e3e171&amp;pbi_source=linkShare&amp;bookmarkGuid=6dfa068f-3726-4d52-80b8-45639808f364&quot;"/>
     <we:property name="reportName" value="&quot;Sample - Financial Data&quot;"/>
     <we:property name="reportState" value="&quot;CONNECTED&quot;"/>
     <we:property name="embedUrl" value="&quot;/reportEmbed?reportId=06ec5cce-0c97-4bba-ac4a-ad9536ee1188&amp;config=eyJjbHVzdGVyVXJsIjoiaHR0cHM6Ly9XQUJJLUJSQVpJTC1TT1VUSC1yZWRpcmVjdC5hbmFseXNpcy53aW5kb3dzLm5ldCIsImVtYmVkRmVhdHVyZXMiOnsidXNhZ2VNZXRyaWNzVk5leHQiOnRydWV9fQ%3D%3D&amp;disableSensitivityBanner=true&quot;"/>
-    <we:property name="pageDisplayName" value="&quot;Geográfico&quot;"/>
+    <we:property name="pageDisplayName" value="&quot;Geográfico2&quot;"/>
     <we:property name="datasetId" value="&quot;24f7b612-ab78-4878-8567-8ec2cbc09cb2&quot;"/>
     <we:property name="backgroundColor" value="&quot;#F6F7F8&quot;"/>
-    <we:property name="bookmark" value="&quot;H4sIAAAAAAAAA+1XyW7bMBD9lYBno9C+5Na6ORRoiqBOAxSFD0Ny5DBgKIGiUruB/71DKm6WGmkQZHGAniTOjGZ5bzikLplUfadh9QXOke2zT0YqAbK1ezGbMDMKkyouK15EcVbLqinjpOYFadvOqdb0bP+SObALdCeqH0B7TyT8MZ8w0PoIFn7VgO5xwjq0fWtAq184GpPK2QHXE4bLTrcWvMuZA4fe7QWZ05pSiN+lFBGEUxc4Q+FGaVNnPColB5FnHGReyzwhs340CJltNfGuQ/hpaxwoQ2G8jDcpFjJOuairuIlE0eSVl/fKLPRVwtffHq86D47DpePt0uPBzyiw97ReU0GQJZxCo6xE3OR1wssseGuUdpuAq4NlZwkrQnD09l5egBEoWQDEYj/Wf8kOEfrBBlQObilm7WAFfsUmqIxTbkV+DlEqCT3ziRzZlnAP4uPWgd6bgcZRddr+nFoktCXbj9ZzktxbqwArbxdKCyvRfliFIj4qu+EmmdzJ8zkKoIxJzaOKo5Bc5DyNsyaFuBC7AfQ3QzqJ/d4JmmuzNwr6tmJGAkrOq6SM0roWcSZyUYGs/0nAlABYtJamjf6Lg2mrh3Pz0KwbZYhK5YfJncSn7WCcXW1BffKyjUCCRrnHsN8pnJ6CdbvQAX+qWM83s5hEZzem7RWpY1pPz+I8DNaoyupSYJyUUHDgMZRFshv7/fE078omv0Gx1ycRSJmXeRNlUcmzSOaYPh7qp2qI7wj23j39ErPlkK4Op3vh2vSGx4vQQ09Mohxh2TpqXm6nb4h9JpbG8ZGkgGXGsyRqYkyjpEiK8v9p9TT3wwd00+veF1/v3Aq9d40EO0f6ZfIv7eD6DgQegcEQvxtdKAx2RDMY6QkI79Y/PytCecT/BPTgoQ8/WCyECdF+AyE8qfvZDQAA&quot;"/>
-    <we:property name="initialStateBookmark" value="&quot;H4sIAAAAAAAAA+1X204bMRD9FeTnqNprNuENUh4qGkCEIlVVVI3t2WBkvCuvlyZF+feOvaRcGgFCXILUp13PzM7lnPGsfcWkamoNiwO4QLbNvhipBMjKbsWsx0wn3D083B/vHO//PNgZ75G4qp2qTMO2r5gDO0N3qpoWtHdBwh/THgOtj2DmVyXoBnusRttUBrT6jZ0xqZxtcdljOK91ZcG7nDhw6N1ekjmtKXb8KaWIIJy6xAkK10nLYcajQnIQecZB5kOZJ2TWdAYhs7Um3nUIP6qMA2UojJfxMsW+jFMuhoO4jES/zAde3igz09cJ33x7sqg9Kg7njldzjwc/p8De03JJBUGWcAqNciDiMh8mvMiCt1Jptwq42JvXlrAiBDtvO/ISjEDJAiAWm67+KzZGaFobUNm7o5hUrRV4jGVQGafcgvyMUSoJDfOJHNmKcA/ik8qB3pqAxk51Vv0aWSS0JduOllOSPFirACvvFkoLK9HuLkIRn5VdcZP07uX5GgVQxqTm0YCjkFzkPI2zMoW4LzYD6G+GdBKbrVM0N2YfFPR1xXQEFJwPkiJKh0MRZyIXA5DDRwkYEQCzytKY0f9wMKp0e2GemnWpDFGp/DC5l/ioao2zizWo9962EUhQKvcc9muFozOwbhM64G8Vy+lqFpPo/Na0vSa1S+vlWZyGwRoNsmEhME4K6HPgMRT9ZDP2+/Np3pRNfotir08ikDIv8jLKooJnkcwxfT7UL9UQ3xHsg3v6LWbLmI4OZ1vhvPSBx4vQbUNMouxgWTtq3m6nr4h9JZa68ZGkgEXGsyQqY0yjpJ/0i/9/q5c5Hz6hm973vPh+/63QezdIsAukK5N/qVrX1CDwCAyG+HXnQmGwI5rBSE9AeLf++VURyh3+p6BbD324YLEQhChRXOMjH/hrFwtphez+AL1KzXsCDgAA&quot;"/>
+    <we:property name="bookmark" value="&quot;H4sIAAAAAAAAA+1WTU/cMBD9K8jnqMrXJhtusN1DRRcQi7hUq2ocTxYjrx05Dt0t2v/escPnFpUeqKASp9jP45nnN0+xb5iQXatgcwwrZPvsixayBmHsXsIipgfw8OTkaHZwdvT9+GA2Jdi0Thrdsf0b5sAu0V3IrgflUxD4bRExUOoUln7WgOowYi3azmhQ8icOwbTkbI/biOG6VcaCTzl34NCnvaZwmlPt5FNGFaF28hrnWLsBzZMyhWqUFHGGMM7KKi6QwrohIDB7NsSnDuUnRjuQmsp4bNTUzTjNqopDVmBcjBvgHu+kXqpbwg97zzetV8Xh2nGz9nrwKyrsM223dKBEYJM1eZliWSfpKOFxXvvdjVTutiDfTNetJa1IwSHbhE6+NJbEVyxoYrEbJLhhE6P6VRhNn+Bz09saz7AJS9pJt6FMjdSga+kl9mxOrSHxw8rE9NrZTYAvzY+JRSoq2H68je55HIhr2k3oLokZQtdb/FsWMxRSwG8Uzo0DtTcHhd0zNBaE/FHzVuLkEqx7KjpNrEB7uAmCfpb2zidptMP1Xxxiu7jzJ4VcPXLgbUsHVq/fw0UwWwpxUjSYlzVyHmeCN6PkRbO9aZOjd+L5F822gnbXZ2/X53KcQS2SSqRNXZWIMeb846fy2G8ENNL9943OizTjMdR5lSNUScF5Xnw0+nUa/Z6uj/tTvOX9ERz3IAVbIT3n/MD0rmuhxlPQGOq3QwqJIY6aC1p41cPY+u9XSf4cRL8A1Xu9w+OPhSLUB8kVvrDBPwlZoBXY/QJzer8lngoAAA==&quot;"/>
+    <we:property name="initialStateBookmark" value="&quot;H4sIAAAAAAAAA+1WTU/cMBD9K8jnqMrXJhtusN1DRRcQi7hUq2ocTxYjrx05Dt0t2v/escPnFpUeqKASp9jP45nnN0+xb5iQXatgcwwrZPvsixayBmHsXsIipgfw8OTkaHZwdvT9+GA2Jdi0Thrdsf0b5sAu0V3IrgflUxD4bRExUOoUln7WgOowYi3azmhQ8icOwbTkbI/biOG6VcaCTzl34NCnvaZwmlPt5FNGFaF28hrnWLsBzZMyhWqUFHGGMM7KKi6QwrohIDB7NsSnDuUnRjuQmsp4bNTUzTjNqopDVmBcjBvgHu+kXqpbwg97zzetV8Xh2nGz9nrwKyrsM223dKBEYJM1eZliWSfpKOFxXvvdjVTutiDfTNetJa1IwSHbhE6+NJbEVyxoYrEbJLhhE6P6VRhNn+Bz09saz7AJS9pJt6FMjdSga+kl9mxOrSHxw8rE9NrZTYAvzY+JRSoq2H68je55HIhr2k3oLokZQtdb/FsWMxRSwG8Uzo0DtTcHhd0zNBaE/FHzVuLkEqx7KjpNrEB7uAmCfpb2zidptMP1Xxxiu7jzJ4VcPXLgbUsHVq/fw0UwWwpxUjSYlzVyHmeCN6PkRbO9aZOjd+L5F822gnbXZ2/X53KcQS2SSqRNXZWIMeb846fy2G8ENNL9943OizTjMdR5lSNUScF5Xnw0+nUa/Z6uj/tTvOX9ERz3IAVbIT3n/MD0rmuhxlPQGOq3QwqJIY6aC1p41cPY+u9XSf4cRL8A1Xu9w+OPhSLUB8kVvrDBPwlZoBXY/QJzer8lngoAAA==&quot;"/>
     <we:property name="isFiltersActionButtonVisible" value="true"/>
     <we:property name="isVisualContainerHeaderHidden" value="false"/>
-    <we:property name="reportEmbeddedTime" value="&quot;2024-06-19T16:27:31.551Z&quot;"/>
+    <we:property name="reportEmbeddedTime" value="&quot;2024-06-19T17:05:26.974Z&quot;"/>
     <we:property name="creatorTenantId" value="&quot;e2aa239f-a4fc-47c9-95a0-e1cf88e3e171&quot;"/>
     <we:property name="creatorUserId" value="&quot;10032000ED6ECE74&quot;"/>
-    <we:property name="creatorSessionId" value="&quot;a54d71c8-1ea6-4f8a-acf6-1dd9ccc89e61&quot;"/>
+    <we:property name="creatorSessionId" value="&quot;98905572-b972-4186-908e-25ed220cb199&quot;"/>
     <we:property name="artifactViewState" value="&quot;live&quot;"/>
   </we:properties>
   <we:bindings/>

</xml_diff>